<commit_message>
Add GitHub repo link to deck slide 6
The deck's link oval now points to the public repository
(github.com/vaishak2k6/APAAR-Satya) as a clickable hyperlink.
PPTX and PDF rebuilt; slide copy updated to match.

Co-Authored-By: Claude Opus 5.5 <noreply@anthropic.com>
</commit_message>
<xml_diff>
--- a/APAAR-Satya_SIH2026_Final.pptx
+++ b/APAAR-Satya_SIH2026_Final.pptx
@@ -6049,7 +6049,7 @@
       </p:pic>
       <p:pic>
         <p:nvPicPr>
-          <p:cNvPr id="15362" name="Picture 15361" descr="image3.png"/>
+          <p:cNvPr id="15362" name="Picture 15361" descr="team_logo.png"/>
           <p:cNvPicPr>
             <a:picLocks noChangeAspect="1"/>
           </p:cNvPicPr>
@@ -7484,7 +7484,7 @@
       </p:pic>
       <p:pic>
         <p:nvPicPr>
-          <p:cNvPr id="17410" name="Picture 17409" descr="image3.png"/>
+          <p:cNvPr id="17410" name="Picture 17409" descr="team_logo.png"/>
           <p:cNvPicPr>
             <a:picLocks noChangeAspect="1"/>
           </p:cNvPicPr>
@@ -11256,7 +11256,7 @@
       </p:pic>
       <p:pic>
         <p:nvPicPr>
-          <p:cNvPr id="17410" name="Picture 17409" descr="image3.png"/>
+          <p:cNvPr id="17410" name="Picture 17409" descr="team_logo.png"/>
           <p:cNvPicPr>
             <a:picLocks noChangeAspect="1"/>
           </p:cNvPicPr>
@@ -12314,7 +12314,7 @@
       </p:pic>
       <p:pic>
         <p:nvPicPr>
-          <p:cNvPr id="17410" name="Picture 17409" descr="image3.png"/>
+          <p:cNvPr id="17410" name="Picture 17409" descr="team_logo.png"/>
           <p:cNvPicPr>
             <a:picLocks noChangeAspect="1"/>
           </p:cNvPicPr>
@@ -13497,7 +13497,7 @@
       </p:pic>
       <p:pic>
         <p:nvPicPr>
-          <p:cNvPr id="17410" name="Picture 17409" descr="image3.png"/>
+          <p:cNvPr id="17410" name="Picture 17409" descr="team_logo.png"/>
           <p:cNvPicPr>
             <a:picLocks noChangeAspect="1"/>
           </p:cNvPicPr>
@@ -14800,8 +14800,8 @@
         </p:nvSpPr>
         <p:spPr>
           <a:xfrm>
-            <a:off x="9418320" y="4828032"/>
-            <a:ext cx="2377440" cy="1280160"/>
+            <a:off x="9372600" y="4828032"/>
+            <a:ext cx="2468880" cy="1280160"/>
           </a:xfrm>
           <a:prstGeom prst="rect">
             <a:avLst/>
@@ -14850,13 +14850,14 @@
           <a:p>
             <a:pPr algn="ctr"/>
             <a:r>
-              <a:rPr sz="1300" b="0" i="0">
+              <a:rPr sz="1050" b="0" i="0" u="sng">
                 <a:solidFill>
                   <a:srgbClr val="1F4E79"/>
                 </a:solidFill>
                 <a:latin typeface="Times New Roman"/>
-              </a:rPr>
-              <a:t>[add repo link]</a:t>
+                <a:hlinkClick r:id="rId9"/>
+              </a:rPr>
+              <a:t>github.com/vaishak2k6/APAAR-Satya</a:t>
             </a:r>
           </a:p>
         </p:txBody>

</xml_diff>

<commit_message>
Publish live demo on GitHub Pages and link it from the deck
- frontend: `npm run build:pages` builds a static export with the
  /APAAR-Satya base path; institution detail pages are pre-rendered
  via generateStaticParams. Normal `npm run dev` / `build` unchanged.
- The static site is served from the gh-pages branch at
  https://vaishak2k6.github.io/APAAR-Satya/
- Deck slide 6 now links to the live demo and the repo (PPTX + PDF
  rebuilt); README documents how to republish the demo.

Co-Authored-By: Claude Opus 5.5 <noreply@anthropic.com>
</commit_message>
<xml_diff>
--- a/APAAR-Satya_SIH2026_Final.pptx
+++ b/APAAR-Satya_SIH2026_Final.pptx
@@ -14826,36 +14826,37 @@
           <a:p>
             <a:pPr algn="ctr"/>
             <a:r>
+              <a:rPr sz="1050" b="0" i="0" u="sng">
+                <a:solidFill>
+                  <a:srgbClr val="1F4E79"/>
+                </a:solidFill>
+                <a:latin typeface="Times New Roman"/>
+                <a:hlinkClick r:id="rId9"/>
+              </a:rPr>
+              <a:t>vaishak2k6.github.io/APAAR-Satya</a:t>
+            </a:r>
+          </a:p>
+          <a:p>
+            <a:pPr algn="ctr"/>
+            <a:r>
               <a:rPr sz="1300" b="0" i="0">
                 <a:solidFill>
+                  <a:srgbClr val="111827"/>
+                </a:solidFill>
+                <a:latin typeface="Times New Roman"/>
+              </a:rPr>
+              <a:t>GitHub link:</a:t>
+            </a:r>
+          </a:p>
+          <a:p>
+            <a:pPr algn="ctr"/>
+            <a:r>
+              <a:rPr sz="1050" b="0" i="0" u="sng">
+                <a:solidFill>
                   <a:srgbClr val="1F4E79"/>
                 </a:solidFill>
                 <a:latin typeface="Times New Roman"/>
-              </a:rPr>
-              <a:t>[add deployed link]</a:t>
-            </a:r>
-          </a:p>
-          <a:p>
-            <a:pPr algn="ctr"/>
-            <a:r>
-              <a:rPr sz="1300" b="0" i="0">
-                <a:solidFill>
-                  <a:srgbClr val="111827"/>
-                </a:solidFill>
-                <a:latin typeface="Times New Roman"/>
-              </a:rPr>
-              <a:t>GitHub link:</a:t>
-            </a:r>
-          </a:p>
-          <a:p>
-            <a:pPr algn="ctr"/>
-            <a:r>
-              <a:rPr sz="1050" b="0" i="0" u="sng">
-                <a:solidFill>
-                  <a:srgbClr val="1F4E79"/>
-                </a:solidFill>
-                <a:latin typeface="Times New Roman"/>
-                <a:hlinkClick r:id="rId9"/>
+                <a:hlinkClick r:id="rId10"/>
               </a:rPr>
               <a:t>github.com/vaishak2k6/APAAR-Satya</a:t>
             </a:r>

</xml_diff>